<commit_message>
chore: add redesigned presentations
</commit_message>
<xml_diff>
--- a/output/Devoir N°2_redesigned.pptx
+++ b/output/Devoir N°2_redesigned.pptx
@@ -2262,7 +2262,7 @@
             <p:par>
               <p:cTn id="10" fill="hold" presetID="10" presetClass="entr" presetSubtype="0" dur="600" nodeType="clickEffect">
                 <p:stCondLst>
-                  <p:cond delay="0" evt="onClick"/>
+                  <p:cond evt="onClick" delay="0"/>
                 </p:stCondLst>
                 <p:childTnLst/>
               </p:cTn>
@@ -2340,7 +2340,7 @@
               </p:cTn>
             </p:par>
             <p:par>
-              <p:cTn id="20" fill="hold" presetID="10" presetClass="entr" presetSubtype="0" dur="700" nodeType="clickEffect">
+              <p:cTn id="20" fill="hold" presetID="10" presetClass="entr" presetSubtype="0" dur="600" nodeType="clickEffect">
                 <p:stCondLst>
                   <p:cond delay="2000"/>
                 </p:stCondLst>
@@ -3569,8 +3569,8 @@
         </p:nvSpPr>
         <p:spPr>
           <a:xfrm>
-            <a:off x="467556" y="79532"/>
-            <a:ext cx="1833644" cy="36576"/>
+            <a:off x="597092" y="88895"/>
+            <a:ext cx="2357286" cy="36576"/>
           </a:xfrm>
           <a:prstGeom prst="rect">
             <a:avLst/>
@@ -3615,9 +3615,9 @@
         <p:cTn id="1" dur="indefinite" restart="whenNotActive" nodeType="tmRoot">
           <p:childTnLst>
             <p:par>
-              <p:cTn id="10" fill="hold" presetID="10" presetClass="entr" presetSubtype="0" dur="700" nodeType="clickEffect">
-                <p:stCondLst>
-                  <p:cond delay="0" evt="onClick"/>
+              <p:cTn id="10" fill="hold" presetID="10" presetClass="entr" presetSubtype="0" dur="600" nodeType="clickEffect">
+                <p:stCondLst>
+                  <p:cond evt="onClick" delay="0"/>
                 </p:stCondLst>
                 <p:childTnLst/>
               </p:cTn>
@@ -3695,7 +3695,7 @@
               </p:cTn>
             </p:par>
             <p:par>
-              <p:cTn id="20" fill="hold" presetID="10" presetClass="entr" presetSubtype="0" dur="500" nodeType="clickEffect">
+              <p:cTn id="20" fill="hold" presetID="10" presetClass="entr" presetSubtype="0" dur="600" nodeType="clickEffect">
                 <p:stCondLst>
                   <p:cond delay="2000"/>
                 </p:stCondLst>
@@ -4688,6 +4688,208 @@
   <p:clrMapOvr>
     <a:masterClrMapping/>
   </p:clrMapOvr>
+  <p:timing>
+    <p:tnLst>
+      <p:par>
+        <p:cTn id="1" dur="indefinite" restart="whenNotActive" nodeType="tmRoot">
+          <p:childTnLst>
+            <p:par>
+              <p:cTn id="10" fill="hold" presetID="10" presetClass="entr" presetSubtype="0" dur="600" nodeType="clickEffect">
+                <p:stCondLst>
+                  <p:cond evt="onClick" delay="0"/>
+                </p:stCondLst>
+                <p:childTnLst/>
+              </p:cTn>
+            </p:par>
+            <p:par>
+              <p:cTn id="11" fill="hold" presetID="10" presetClass="entr" presetSubtype="0" dur="600" nodeType="clickEffect">
+                <p:stCondLst>
+                  <p:cond delay="200"/>
+                </p:stCondLst>
+                <p:childTnLst/>
+              </p:cTn>
+            </p:par>
+            <p:par>
+              <p:cTn id="12" fill="hold" presetID="10" presetClass="entr" presetSubtype="0" dur="600" nodeType="clickEffect">
+                <p:stCondLst>
+                  <p:cond delay="400"/>
+                </p:stCondLst>
+                <p:childTnLst/>
+              </p:cTn>
+            </p:par>
+            <p:par>
+              <p:cTn id="13" fill="hold" presetID="10" presetClass="entr" presetSubtype="0" dur="600" nodeType="clickEffect">
+                <p:stCondLst>
+                  <p:cond delay="600"/>
+                </p:stCondLst>
+                <p:childTnLst/>
+              </p:cTn>
+            </p:par>
+            <p:par>
+              <p:cTn id="14" fill="hold" presetID="10" presetClass="entr" presetSubtype="0" dur="600" nodeType="clickEffect">
+                <p:stCondLst>
+                  <p:cond delay="800"/>
+                </p:stCondLst>
+                <p:childTnLst/>
+              </p:cTn>
+            </p:par>
+            <p:par>
+              <p:cTn id="15" fill="hold" presetID="10" presetClass="entr" presetSubtype="0" dur="600" nodeType="clickEffect">
+                <p:stCondLst>
+                  <p:cond delay="1000"/>
+                </p:stCondLst>
+                <p:childTnLst/>
+              </p:cTn>
+            </p:par>
+            <p:par>
+              <p:cTn id="16" fill="hold" presetID="10" presetClass="entr" presetSubtype="0" dur="600" nodeType="clickEffect">
+                <p:stCondLst>
+                  <p:cond delay="1200"/>
+                </p:stCondLst>
+                <p:childTnLst/>
+              </p:cTn>
+            </p:par>
+            <p:par>
+              <p:cTn id="17" fill="hold" presetID="10" presetClass="entr" presetSubtype="0" dur="600" nodeType="clickEffect">
+                <p:stCondLst>
+                  <p:cond delay="1400"/>
+                </p:stCondLst>
+                <p:childTnLst/>
+              </p:cTn>
+            </p:par>
+            <p:par>
+              <p:cTn id="18" fill="hold" presetID="10" presetClass="entr" presetSubtype="0" dur="600" nodeType="clickEffect">
+                <p:stCondLst>
+                  <p:cond delay="1600"/>
+                </p:stCondLst>
+                <p:childTnLst/>
+              </p:cTn>
+            </p:par>
+            <p:par>
+              <p:cTn id="19" fill="hold" presetID="10" presetClass="entr" presetSubtype="0" dur="600" nodeType="clickEffect">
+                <p:stCondLst>
+                  <p:cond delay="1800"/>
+                </p:stCondLst>
+                <p:childTnLst/>
+              </p:cTn>
+            </p:par>
+            <p:par>
+              <p:cTn id="20" fill="hold" presetID="10" presetClass="entr" presetSubtype="0" dur="600" nodeType="clickEffect">
+                <p:stCondLst>
+                  <p:cond delay="2000"/>
+                </p:stCondLst>
+                <p:childTnLst/>
+              </p:cTn>
+            </p:par>
+            <p:par>
+              <p:cTn id="21" fill="hold" presetID="10" presetClass="entr" presetSubtype="0" dur="700" nodeType="clickEffect">
+                <p:stCondLst>
+                  <p:cond delay="2200"/>
+                </p:stCondLst>
+                <p:childTnLst/>
+              </p:cTn>
+            </p:par>
+            <p:par>
+              <p:cTn id="22" fill="hold" presetID="10" presetClass="entr" presetSubtype="0" dur="600" nodeType="clickEffect">
+                <p:stCondLst>
+                  <p:cond delay="2400"/>
+                </p:stCondLst>
+                <p:childTnLst/>
+              </p:cTn>
+            </p:par>
+            <p:par>
+              <p:cTn id="23" fill="hold" presetID="10" presetClass="entr" presetSubtype="0" dur="600" nodeType="clickEffect">
+                <p:stCondLst>
+                  <p:cond delay="2600"/>
+                </p:stCondLst>
+                <p:childTnLst/>
+              </p:cTn>
+            </p:par>
+            <p:par>
+              <p:cTn id="24" fill="hold" presetID="10" presetClass="entr" presetSubtype="0" dur="600" nodeType="clickEffect">
+                <p:stCondLst>
+                  <p:cond delay="2800"/>
+                </p:stCondLst>
+                <p:childTnLst/>
+              </p:cTn>
+            </p:par>
+            <p:par>
+              <p:cTn id="25" fill="hold" presetID="10" presetClass="entr" presetSubtype="0" dur="600" nodeType="clickEffect">
+                <p:stCondLst>
+                  <p:cond delay="3000"/>
+                </p:stCondLst>
+                <p:childTnLst/>
+              </p:cTn>
+            </p:par>
+            <p:par>
+              <p:cTn id="26" fill="hold" presetID="10" presetClass="entr" presetSubtype="0" dur="600" nodeType="clickEffect">
+                <p:stCondLst>
+                  <p:cond delay="3200"/>
+                </p:stCondLst>
+                <p:childTnLst/>
+              </p:cTn>
+            </p:par>
+            <p:par>
+              <p:cTn id="27" fill="hold" presetID="10" presetClass="entr" presetSubtype="0" dur="600" nodeType="clickEffect">
+                <p:stCondLst>
+                  <p:cond delay="3400"/>
+                </p:stCondLst>
+                <p:childTnLst/>
+              </p:cTn>
+            </p:par>
+            <p:par>
+              <p:cTn id="28" fill="hold" presetID="10" presetClass="entr" presetSubtype="0" dur="600" nodeType="clickEffect">
+                <p:stCondLst>
+                  <p:cond delay="3600"/>
+                </p:stCondLst>
+                <p:childTnLst/>
+              </p:cTn>
+            </p:par>
+            <p:par>
+              <p:cTn id="29" fill="hold" presetID="10" presetClass="entr" presetSubtype="0" dur="600" nodeType="clickEffect">
+                <p:stCondLst>
+                  <p:cond delay="3800"/>
+                </p:stCondLst>
+                <p:childTnLst/>
+              </p:cTn>
+            </p:par>
+            <p:par>
+              <p:cTn id="30" fill="hold" presetID="10" presetClass="entr" presetSubtype="0" dur="700" nodeType="clickEffect">
+                <p:stCondLst>
+                  <p:cond delay="4000"/>
+                </p:stCondLst>
+                <p:childTnLst/>
+              </p:cTn>
+            </p:par>
+            <p:par>
+              <p:cTn id="31" fill="hold" presetID="10" presetClass="entr" presetSubtype="0" dur="600" nodeType="clickEffect">
+                <p:stCondLst>
+                  <p:cond delay="4200"/>
+                </p:stCondLst>
+                <p:childTnLst/>
+              </p:cTn>
+            </p:par>
+            <p:par>
+              <p:cTn id="32" fill="hold" presetID="10" presetClass="entr" presetSubtype="0" dur="600" nodeType="clickEffect">
+                <p:stCondLst>
+                  <p:cond delay="4400"/>
+                </p:stCondLst>
+                <p:childTnLst/>
+              </p:cTn>
+            </p:par>
+            <p:par>
+              <p:cTn id="33" fill="hold" presetID="10" presetClass="entr" presetSubtype="0" dur="600" nodeType="clickEffect">
+                <p:stCondLst>
+                  <p:cond delay="4600"/>
+                </p:stCondLst>
+                <p:childTnLst/>
+              </p:cTn>
+            </p:par>
+          </p:childTnLst>
+        </p:cTn>
+      </p:par>
+    </p:tnLst>
+  </p:timing>
 </p:sld>
 </file>
 
@@ -5639,8 +5841,8 @@
         </p:nvSpPr>
         <p:spPr>
           <a:xfrm>
-            <a:off x="557418" y="103400"/>
-            <a:ext cx="2470819" cy="36576"/>
+            <a:off x="783598" y="132177"/>
+            <a:ext cx="2986825" cy="36576"/>
           </a:xfrm>
           <a:prstGeom prst="rect">
             <a:avLst/>
@@ -5685,9 +5887,9 @@
         <p:cTn id="1" dur="indefinite" restart="whenNotActive" nodeType="tmRoot">
           <p:childTnLst>
             <p:par>
-              <p:cTn id="10" fill="hold" presetID="10" presetClass="entr" presetSubtype="0" dur="600" nodeType="clickEffect">
-                <p:stCondLst>
-                  <p:cond delay="0" evt="onClick"/>
+              <p:cTn id="10" fill="hold" presetID="10" presetClass="entr" presetSubtype="0" dur="500" nodeType="clickEffect">
+                <p:stCondLst>
+                  <p:cond evt="onClick" delay="0"/>
                 </p:stCondLst>
                 <p:childTnLst/>
               </p:cTn>
@@ -5741,7 +5943,7 @@
               </p:cTn>
             </p:par>
             <p:par>
-              <p:cTn id="17" fill="hold" presetID="10" presetClass="entr" presetSubtype="0" dur="600" nodeType="clickEffect">
+              <p:cTn id="17" fill="hold" presetID="10" presetClass="entr" presetSubtype="0" dur="700" nodeType="clickEffect">
                 <p:stCondLst>
                   <p:cond delay="1400"/>
                 </p:stCondLst>
@@ -5749,7 +5951,7 @@
               </p:cTn>
             </p:par>
             <p:par>
-              <p:cTn id="18" fill="hold" presetID="10" presetClass="entr" presetSubtype="0" dur="600" nodeType="clickEffect">
+              <p:cTn id="18" fill="hold" presetID="10" presetClass="entr" presetSubtype="0" dur="700" nodeType="clickEffect">
                 <p:stCondLst>
                   <p:cond delay="1600"/>
                 </p:stCondLst>
@@ -5773,7 +5975,7 @@
               </p:cTn>
             </p:par>
             <p:par>
-              <p:cTn id="21" fill="hold" presetID="10" presetClass="entr" presetSubtype="0" dur="500" nodeType="clickEffect">
+              <p:cTn id="21" fill="hold" presetID="10" presetClass="entr" presetSubtype="0" dur="600" nodeType="clickEffect">
                 <p:stCondLst>
                   <p:cond delay="2200"/>
                 </p:stCondLst>
@@ -5829,7 +6031,7 @@
               </p:cTn>
             </p:par>
             <p:par>
-              <p:cTn id="28" fill="hold" presetID="10" presetClass="entr" presetSubtype="0" dur="700" nodeType="clickEffect">
+              <p:cTn id="28" fill="hold" presetID="10" presetClass="entr" presetSubtype="0" dur="600" nodeType="clickEffect">
                 <p:stCondLst>
                   <p:cond delay="3600"/>
                 </p:stCondLst>
@@ -7052,8 +7254,8 @@
         </p:nvSpPr>
         <p:spPr>
           <a:xfrm>
-            <a:off x="794007" y="122229"/>
-            <a:ext cx="2122346" cy="36576"/>
+            <a:off x="852051" y="135197"/>
+            <a:ext cx="1679796" cy="36576"/>
           </a:xfrm>
           <a:prstGeom prst="rect">
             <a:avLst/>
@@ -7100,7 +7302,7 @@
             <p:par>
               <p:cTn id="10" fill="hold" presetID="10" presetClass="entr" presetSubtype="0" dur="600" nodeType="clickEffect">
                 <p:stCondLst>
-                  <p:cond delay="0" evt="onClick"/>
+                  <p:cond evt="onClick" delay="0"/>
                 </p:stCondLst>
                 <p:childTnLst/>
               </p:cTn>
@@ -7146,7 +7348,7 @@
               </p:cTn>
             </p:par>
             <p:par>
-              <p:cTn id="16" fill="hold" presetID="10" presetClass="entr" presetSubtype="0" dur="500" nodeType="clickEffect">
+              <p:cTn id="16" fill="hold" presetID="10" presetClass="entr" presetSubtype="0" dur="600" nodeType="clickEffect">
                 <p:stCondLst>
                   <p:cond delay="1200"/>
                 </p:stCondLst>
@@ -7186,7 +7388,7 @@
               </p:cTn>
             </p:par>
             <p:par>
-              <p:cTn id="21" fill="hold" presetID="10" presetClass="entr" presetSubtype="0" dur="600" nodeType="clickEffect">
+              <p:cTn id="21" fill="hold" presetID="10" presetClass="entr" presetSubtype="0" dur="500" nodeType="clickEffect">
                 <p:stCondLst>
                   <p:cond delay="2200"/>
                 </p:stCondLst>
@@ -7194,7 +7396,7 @@
               </p:cTn>
             </p:par>
             <p:par>
-              <p:cTn id="22" fill="hold" presetID="10" presetClass="entr" presetSubtype="0" dur="600" nodeType="clickEffect">
+              <p:cTn id="22" fill="hold" presetID="10" presetClass="entr" presetSubtype="0" dur="500" nodeType="clickEffect">
                 <p:stCondLst>
                   <p:cond delay="2400"/>
                 </p:stCondLst>
@@ -7202,7 +7404,7 @@
               </p:cTn>
             </p:par>
             <p:par>
-              <p:cTn id="23" fill="hold" presetID="10" presetClass="entr" presetSubtype="0" dur="500" nodeType="clickEffect">
+              <p:cTn id="23" fill="hold" presetID="10" presetClass="entr" presetSubtype="0" dur="600" nodeType="clickEffect">
                 <p:stCondLst>
                   <p:cond delay="2600"/>
                 </p:stCondLst>
@@ -7210,7 +7412,7 @@
               </p:cTn>
             </p:par>
             <p:par>
-              <p:cTn id="24" fill="hold" presetID="10" presetClass="entr" presetSubtype="0" dur="500" nodeType="clickEffect">
+              <p:cTn id="24" fill="hold" presetID="10" presetClass="entr" presetSubtype="0" dur="600" nodeType="clickEffect">
                 <p:stCondLst>
                   <p:cond delay="2800"/>
                 </p:stCondLst>
@@ -7234,7 +7436,7 @@
               </p:cTn>
             </p:par>
             <p:par>
-              <p:cTn id="27" fill="hold" presetID="10" presetClass="entr" presetSubtype="0" dur="600" nodeType="clickEffect">
+              <p:cTn id="27" fill="hold" presetID="10" presetClass="entr" presetSubtype="0" dur="500" nodeType="clickEffect">
                 <p:stCondLst>
                   <p:cond delay="3400"/>
                 </p:stCondLst>
@@ -7266,7 +7468,7 @@
               </p:cTn>
             </p:par>
             <p:par>
-              <p:cTn id="31" fill="hold" presetID="10" presetClass="entr" presetSubtype="0" dur="500" nodeType="clickEffect">
+              <p:cTn id="31" fill="hold" presetID="10" presetClass="entr" presetSubtype="0" dur="600" nodeType="clickEffect">
                 <p:stCondLst>
                   <p:cond delay="4200"/>
                 </p:stCondLst>
@@ -7282,7 +7484,7 @@
               </p:cTn>
             </p:par>
             <p:par>
-              <p:cTn id="33" fill="hold" presetID="10" presetClass="entr" presetSubtype="0" dur="600" nodeType="clickEffect">
+              <p:cTn id="33" fill="hold" presetID="10" presetClass="entr" presetSubtype="0" dur="500" nodeType="clickEffect">
                 <p:stCondLst>
                   <p:cond delay="4600"/>
                 </p:stCondLst>
@@ -8499,8 +8701,8 @@
         </p:nvSpPr>
         <p:spPr>
           <a:xfrm>
-            <a:off x="747707" y="85779"/>
-            <a:ext cx="2649177" cy="36576"/>
+            <a:off x="658509" y="107236"/>
+            <a:ext cx="1610452" cy="36576"/>
           </a:xfrm>
           <a:prstGeom prst="rect">
             <a:avLst/>
@@ -8547,7 +8749,7 @@
             <p:par>
               <p:cTn id="10" fill="hold" presetID="10" presetClass="entr" presetSubtype="0" dur="600" nodeType="clickEffect">
                 <p:stCondLst>
-                  <p:cond delay="0" evt="onClick"/>
+                  <p:cond evt="onClick" delay="0"/>
                 </p:stCondLst>
                 <p:childTnLst/>
               </p:cTn>
@@ -8561,7 +8763,7 @@
               </p:cTn>
             </p:par>
             <p:par>
-              <p:cTn id="12" fill="hold" presetID="10" presetClass="entr" presetSubtype="0" dur="600" nodeType="clickEffect">
+              <p:cTn id="12" fill="hold" presetID="10" presetClass="entr" presetSubtype="0" dur="700" nodeType="clickEffect">
                 <p:stCondLst>
                   <p:cond delay="400"/>
                 </p:stCondLst>
@@ -8585,7 +8787,7 @@
               </p:cTn>
             </p:par>
             <p:par>
-              <p:cTn id="15" fill="hold" presetID="10" presetClass="entr" presetSubtype="0" dur="600" nodeType="clickEffect">
+              <p:cTn id="15" fill="hold" presetID="10" presetClass="entr" presetSubtype="0" dur="500" nodeType="clickEffect">
                 <p:stCondLst>
                   <p:cond delay="1000"/>
                 </p:stCondLst>
@@ -8681,7 +8883,7 @@
               </p:cTn>
             </p:par>
             <p:par>
-              <p:cTn id="27" fill="hold" presetID="10" presetClass="entr" presetSubtype="0" dur="500" nodeType="clickEffect">
+              <p:cTn id="27" fill="hold" presetID="10" presetClass="entr" presetSubtype="0" dur="600" nodeType="clickEffect">
                 <p:stCondLst>
                   <p:cond delay="3400"/>
                 </p:stCondLst>
@@ -8705,7 +8907,7 @@
               </p:cTn>
             </p:par>
             <p:par>
-              <p:cTn id="30" fill="hold" presetID="10" presetClass="entr" presetSubtype="0" dur="600" nodeType="clickEffect">
+              <p:cTn id="30" fill="hold" presetID="10" presetClass="entr" presetSubtype="0" dur="500" nodeType="clickEffect">
                 <p:stCondLst>
                   <p:cond delay="4000"/>
                 </p:stCondLst>
@@ -8729,7 +8931,7 @@
               </p:cTn>
             </p:par>
             <p:par>
-              <p:cTn id="33" fill="hold" presetID="10" presetClass="entr" presetSubtype="0" dur="600" nodeType="clickEffect">
+              <p:cTn id="33" fill="hold" presetID="10" presetClass="entr" presetSubtype="0" dur="700" nodeType="clickEffect">
                 <p:stCondLst>
                   <p:cond delay="4600"/>
                 </p:stCondLst>
@@ -9697,7 +9899,7 @@
             <p:par>
               <p:cTn id="10" fill="hold" presetID="10" presetClass="entr" presetSubtype="0" dur="600" nodeType="clickEffect">
                 <p:stCondLst>
-                  <p:cond delay="0" evt="onClick"/>
+                  <p:cond evt="onClick" delay="0"/>
                 </p:stCondLst>
                 <p:childTnLst/>
               </p:cTn>
@@ -9719,7 +9921,7 @@
               </p:cTn>
             </p:par>
             <p:par>
-              <p:cTn id="13" fill="hold" presetID="10" presetClass="entr" presetSubtype="0" dur="600" nodeType="clickEffect">
+              <p:cTn id="13" fill="hold" presetID="10" presetClass="entr" presetSubtype="0" dur="700" nodeType="clickEffect">
                 <p:stCondLst>
                   <p:cond delay="600"/>
                 </p:stCondLst>
@@ -9743,7 +9945,7 @@
               </p:cTn>
             </p:par>
             <p:par>
-              <p:cTn id="16" fill="hold" presetID="10" presetClass="entr" presetSubtype="0" dur="600" nodeType="clickEffect">
+              <p:cTn id="16" fill="hold" presetID="10" presetClass="entr" presetSubtype="0" dur="700" nodeType="clickEffect">
                 <p:stCondLst>
                   <p:cond delay="1200"/>
                 </p:stCondLst>
@@ -9815,7 +10017,7 @@
               </p:cTn>
             </p:par>
             <p:par>
-              <p:cTn id="25" fill="hold" presetID="10" presetClass="entr" presetSubtype="0" dur="700" nodeType="clickEffect">
+              <p:cTn id="25" fill="hold" presetID="10" presetClass="entr" presetSubtype="0" dur="600" nodeType="clickEffect">
                 <p:stCondLst>
                   <p:cond delay="3000"/>
                 </p:stCondLst>
@@ -9839,7 +10041,7 @@
               </p:cTn>
             </p:par>
             <p:par>
-              <p:cTn id="28" fill="hold" presetID="10" presetClass="entr" presetSubtype="0" dur="600" nodeType="clickEffect">
+              <p:cTn id="28" fill="hold" presetID="10" presetClass="entr" presetSubtype="0" dur="500" nodeType="clickEffect">
                 <p:stCondLst>
                   <p:cond delay="3600"/>
                 </p:stCondLst>
@@ -10936,8 +11138,8 @@
         </p:nvSpPr>
         <p:spPr>
           <a:xfrm>
-            <a:off x="711838" y="128202"/>
-            <a:ext cx="2046150" cy="36576"/>
+            <a:off x="593069" y="101455"/>
+            <a:ext cx="1914588" cy="36576"/>
           </a:xfrm>
           <a:prstGeom prst="rect">
             <a:avLst/>
@@ -10984,13 +11186,13 @@
             <p:par>
               <p:cTn id="10" fill="hold" presetID="10" presetClass="entr" presetSubtype="0" dur="600" nodeType="clickEffect">
                 <p:stCondLst>
-                  <p:cond delay="0" evt="onClick"/>
-                </p:stCondLst>
-                <p:childTnLst/>
-              </p:cTn>
-            </p:par>
-            <p:par>
-              <p:cTn id="11" fill="hold" presetID="10" presetClass="entr" presetSubtype="0" dur="500" nodeType="clickEffect">
+                  <p:cond evt="onClick" delay="0"/>
+                </p:stCondLst>
+                <p:childTnLst/>
+              </p:cTn>
+            </p:par>
+            <p:par>
+              <p:cTn id="11" fill="hold" presetID="10" presetClass="entr" presetSubtype="0" dur="600" nodeType="clickEffect">
                 <p:stCondLst>
                   <p:cond delay="200"/>
                 </p:stCondLst>
@@ -11014,7 +11216,7 @@
               </p:cTn>
             </p:par>
             <p:par>
-              <p:cTn id="14" fill="hold" presetID="10" presetClass="entr" presetSubtype="0" dur="700" nodeType="clickEffect">
+              <p:cTn id="14" fill="hold" presetID="10" presetClass="entr" presetSubtype="0" dur="600" nodeType="clickEffect">
                 <p:stCondLst>
                   <p:cond delay="800"/>
                 </p:stCondLst>
@@ -11054,7 +11256,7 @@
               </p:cTn>
             </p:par>
             <p:par>
-              <p:cTn id="19" fill="hold" presetID="10" presetClass="entr" presetSubtype="0" dur="600" nodeType="clickEffect">
+              <p:cTn id="19" fill="hold" presetID="10" presetClass="entr" presetSubtype="0" dur="500" nodeType="clickEffect">
                 <p:stCondLst>
                   <p:cond delay="1800"/>
                 </p:stCondLst>
@@ -11198,7 +11400,7 @@
               </p:cTn>
             </p:par>
             <p:par>
-              <p:cTn id="37" fill="hold" presetID="10" presetClass="entr" presetSubtype="0" dur="600" nodeType="clickEffect">
+              <p:cTn id="37" fill="hold" presetID="10" presetClass="entr" presetSubtype="0" dur="700" nodeType="clickEffect">
                 <p:stCondLst>
                   <p:cond delay="5400"/>
                 </p:stCondLst>
@@ -12160,8 +12362,8 @@
         </p:nvSpPr>
         <p:spPr>
           <a:xfrm>
-            <a:off x="894292" y="114100"/>
-            <a:ext cx="1765894" cy="36576"/>
+            <a:off x="701874" y="120304"/>
+            <a:ext cx="1922544" cy="36576"/>
           </a:xfrm>
           <a:prstGeom prst="rect">
             <a:avLst/>
@@ -12208,7 +12410,7 @@
             <p:par>
               <p:cTn id="10" fill="hold" presetID="10" presetClass="entr" presetSubtype="0" dur="600" nodeType="clickEffect">
                 <p:stCondLst>
-                  <p:cond delay="0" evt="onClick"/>
+                  <p:cond evt="onClick" delay="0"/>
                 </p:stCondLst>
                 <p:childTnLst/>
               </p:cTn>
@@ -12222,7 +12424,7 @@
               </p:cTn>
             </p:par>
             <p:par>
-              <p:cTn id="12" fill="hold" presetID="10" presetClass="entr" presetSubtype="0" dur="700" nodeType="clickEffect">
+              <p:cTn id="12" fill="hold" presetID="10" presetClass="entr" presetSubtype="0" dur="600" nodeType="clickEffect">
                 <p:stCondLst>
                   <p:cond delay="400"/>
                 </p:stCondLst>
@@ -12246,7 +12448,7 @@
               </p:cTn>
             </p:par>
             <p:par>
-              <p:cTn id="15" fill="hold" presetID="10" presetClass="entr" presetSubtype="0" dur="700" nodeType="clickEffect">
+              <p:cTn id="15" fill="hold" presetID="10" presetClass="entr" presetSubtype="0" dur="600" nodeType="clickEffect">
                 <p:stCondLst>
                   <p:cond delay="1000"/>
                 </p:stCondLst>
@@ -12254,7 +12456,7 @@
               </p:cTn>
             </p:par>
             <p:par>
-              <p:cTn id="16" fill="hold" presetID="10" presetClass="entr" presetSubtype="0" dur="500" nodeType="clickEffect">
+              <p:cTn id="16" fill="hold" presetID="10" presetClass="entr" presetSubtype="0" dur="600" nodeType="clickEffect">
                 <p:stCondLst>
                   <p:cond delay="1200"/>
                 </p:stCondLst>
@@ -12262,7 +12464,7 @@
               </p:cTn>
             </p:par>
             <p:par>
-              <p:cTn id="17" fill="hold" presetID="10" presetClass="entr" presetSubtype="0" dur="600" nodeType="clickEffect">
+              <p:cTn id="17" fill="hold" presetID="10" presetClass="entr" presetSubtype="0" dur="700" nodeType="clickEffect">
                 <p:stCondLst>
                   <p:cond delay="1400"/>
                 </p:stCondLst>
@@ -12302,7 +12504,7 @@
               </p:cTn>
             </p:par>
             <p:par>
-              <p:cTn id="22" fill="hold" presetID="10" presetClass="entr" presetSubtype="0" dur="600" nodeType="clickEffect">
+              <p:cTn id="22" fill="hold" presetID="10" presetClass="entr" presetSubtype="0" dur="500" nodeType="clickEffect">
                 <p:stCondLst>
                   <p:cond delay="2400"/>
                 </p:stCondLst>
@@ -12310,7 +12512,7 @@
               </p:cTn>
             </p:par>
             <p:par>
-              <p:cTn id="23" fill="hold" presetID="10" presetClass="entr" presetSubtype="0" dur="600" nodeType="clickEffect">
+              <p:cTn id="23" fill="hold" presetID="10" presetClass="entr" presetSubtype="0" dur="500" nodeType="clickEffect">
                 <p:stCondLst>
                   <p:cond delay="2600"/>
                 </p:stCondLst>
@@ -12326,7 +12528,7 @@
               </p:cTn>
             </p:par>
             <p:par>
-              <p:cTn id="25" fill="hold" presetID="10" presetClass="entr" presetSubtype="0" dur="700" nodeType="clickEffect">
+              <p:cTn id="25" fill="hold" presetID="10" presetClass="entr" presetSubtype="0" dur="600" nodeType="clickEffect">
                 <p:stCondLst>
                   <p:cond delay="3000"/>
                 </p:stCondLst>
@@ -12350,7 +12552,7 @@
               </p:cTn>
             </p:par>
             <p:par>
-              <p:cTn id="28" fill="hold" presetID="10" presetClass="entr" presetSubtype="0" dur="500" nodeType="clickEffect">
+              <p:cTn id="28" fill="hold" presetID="10" presetClass="entr" presetSubtype="0" dur="600" nodeType="clickEffect">
                 <p:stCondLst>
                   <p:cond delay="3600"/>
                 </p:stCondLst>
@@ -12635,8 +12837,8 @@
         </p:nvSpPr>
         <p:spPr>
           <a:xfrm>
-            <a:off x="825070" y="122418"/>
-            <a:ext cx="2163126" cy="36576"/>
+            <a:off x="466105" y="115935"/>
+            <a:ext cx="1688648" cy="36576"/>
           </a:xfrm>
           <a:prstGeom prst="rect">
             <a:avLst/>
@@ -12675,80 +12877,6 @@
   <p:clrMapOvr>
     <a:masterClrMapping/>
   </p:clrMapOvr>
-  <p:timing>
-    <p:tnLst>
-      <p:par>
-        <p:cTn id="1" dur="indefinite" restart="whenNotActive" nodeType="tmRoot">
-          <p:childTnLst>
-            <p:par>
-              <p:cTn id="10" fill="hold" presetID="10" presetClass="entr" presetSubtype="0" dur="700" nodeType="clickEffect">
-                <p:stCondLst>
-                  <p:cond delay="0" evt="onClick"/>
-                </p:stCondLst>
-                <p:childTnLst/>
-              </p:cTn>
-            </p:par>
-            <p:par>
-              <p:cTn id="11" fill="hold" presetID="10" presetClass="entr" presetSubtype="0" dur="500" nodeType="clickEffect">
-                <p:stCondLst>
-                  <p:cond delay="200"/>
-                </p:stCondLst>
-                <p:childTnLst/>
-              </p:cTn>
-            </p:par>
-            <p:par>
-              <p:cTn id="12" fill="hold" presetID="10" presetClass="entr" presetSubtype="0" dur="600" nodeType="clickEffect">
-                <p:stCondLst>
-                  <p:cond delay="400"/>
-                </p:stCondLst>
-                <p:childTnLst/>
-              </p:cTn>
-            </p:par>
-            <p:par>
-              <p:cTn id="13" fill="hold" presetID="10" presetClass="entr" presetSubtype="0" dur="600" nodeType="clickEffect">
-                <p:stCondLst>
-                  <p:cond delay="600"/>
-                </p:stCondLst>
-                <p:childTnLst/>
-              </p:cTn>
-            </p:par>
-            <p:par>
-              <p:cTn id="14" fill="hold" presetID="10" presetClass="entr" presetSubtype="0" dur="700" nodeType="clickEffect">
-                <p:stCondLst>
-                  <p:cond delay="800"/>
-                </p:stCondLst>
-                <p:childTnLst/>
-              </p:cTn>
-            </p:par>
-            <p:par>
-              <p:cTn id="15" fill="hold" presetID="10" presetClass="entr" presetSubtype="0" dur="600" nodeType="clickEffect">
-                <p:stCondLst>
-                  <p:cond delay="1000"/>
-                </p:stCondLst>
-                <p:childTnLst/>
-              </p:cTn>
-            </p:par>
-            <p:par>
-              <p:cTn id="16" fill="hold" presetID="10" presetClass="entr" presetSubtype="0" dur="600" nodeType="clickEffect">
-                <p:stCondLst>
-                  <p:cond delay="1200"/>
-                </p:stCondLst>
-                <p:childTnLst/>
-              </p:cTn>
-            </p:par>
-            <p:par>
-              <p:cTn id="17" fill="hold" presetID="10" presetClass="entr" presetSubtype="0" dur="600" nodeType="clickEffect">
-                <p:stCondLst>
-                  <p:cond delay="1400"/>
-                </p:stCondLst>
-                <p:childTnLst/>
-              </p:cTn>
-            </p:par>
-          </p:childTnLst>
-        </p:cTn>
-      </p:par>
-    </p:tnLst>
-  </p:timing>
 </p:sld>
 </file>
 
@@ -13759,8 +13887,8 @@
         </p:nvSpPr>
         <p:spPr>
           <a:xfrm>
-            <a:off x="708902" y="115557"/>
-            <a:ext cx="2779435" cy="36576"/>
+            <a:off x="593332" y="111815"/>
+            <a:ext cx="1980389" cy="36576"/>
           </a:xfrm>
           <a:prstGeom prst="rect">
             <a:avLst/>
@@ -13799,6 +13927,192 @@
   <p:clrMapOvr>
     <a:masterClrMapping/>
   </p:clrMapOvr>
+  <p:timing>
+    <p:tnLst>
+      <p:par>
+        <p:cTn id="1" dur="indefinite" restart="whenNotActive" nodeType="tmRoot">
+          <p:childTnLst>
+            <p:par>
+              <p:cTn id="10" fill="hold" presetID="10" presetClass="entr" presetSubtype="0" dur="600" nodeType="clickEffect">
+                <p:stCondLst>
+                  <p:cond evt="onClick" delay="0"/>
+                </p:stCondLst>
+                <p:childTnLst/>
+              </p:cTn>
+            </p:par>
+            <p:par>
+              <p:cTn id="11" fill="hold" presetID="10" presetClass="entr" presetSubtype="0" dur="600" nodeType="clickEffect">
+                <p:stCondLst>
+                  <p:cond delay="200"/>
+                </p:stCondLst>
+                <p:childTnLst/>
+              </p:cTn>
+            </p:par>
+            <p:par>
+              <p:cTn id="12" fill="hold" presetID="10" presetClass="entr" presetSubtype="0" dur="600" nodeType="clickEffect">
+                <p:stCondLst>
+                  <p:cond delay="400"/>
+                </p:stCondLst>
+                <p:childTnLst/>
+              </p:cTn>
+            </p:par>
+            <p:par>
+              <p:cTn id="13" fill="hold" presetID="10" presetClass="entr" presetSubtype="0" dur="600" nodeType="clickEffect">
+                <p:stCondLst>
+                  <p:cond delay="600"/>
+                </p:stCondLst>
+                <p:childTnLst/>
+              </p:cTn>
+            </p:par>
+            <p:par>
+              <p:cTn id="14" fill="hold" presetID="10" presetClass="entr" presetSubtype="0" dur="600" nodeType="clickEffect">
+                <p:stCondLst>
+                  <p:cond delay="800"/>
+                </p:stCondLst>
+                <p:childTnLst/>
+              </p:cTn>
+            </p:par>
+            <p:par>
+              <p:cTn id="15" fill="hold" presetID="10" presetClass="entr" presetSubtype="0" dur="600" nodeType="clickEffect">
+                <p:stCondLst>
+                  <p:cond delay="1000"/>
+                </p:stCondLst>
+                <p:childTnLst/>
+              </p:cTn>
+            </p:par>
+            <p:par>
+              <p:cTn id="16" fill="hold" presetID="10" presetClass="entr" presetSubtype="0" dur="600" nodeType="clickEffect">
+                <p:stCondLst>
+                  <p:cond delay="1200"/>
+                </p:stCondLst>
+                <p:childTnLst/>
+              </p:cTn>
+            </p:par>
+            <p:par>
+              <p:cTn id="17" fill="hold" presetID="10" presetClass="entr" presetSubtype="0" dur="600" nodeType="clickEffect">
+                <p:stCondLst>
+                  <p:cond delay="1400"/>
+                </p:stCondLst>
+                <p:childTnLst/>
+              </p:cTn>
+            </p:par>
+            <p:par>
+              <p:cTn id="18" fill="hold" presetID="10" presetClass="entr" presetSubtype="0" dur="600" nodeType="clickEffect">
+                <p:stCondLst>
+                  <p:cond delay="1600"/>
+                </p:stCondLst>
+                <p:childTnLst/>
+              </p:cTn>
+            </p:par>
+            <p:par>
+              <p:cTn id="19" fill="hold" presetID="10" presetClass="entr" presetSubtype="0" dur="600" nodeType="clickEffect">
+                <p:stCondLst>
+                  <p:cond delay="1800"/>
+                </p:stCondLst>
+                <p:childTnLst/>
+              </p:cTn>
+            </p:par>
+            <p:par>
+              <p:cTn id="20" fill="hold" presetID="10" presetClass="entr" presetSubtype="0" dur="600" nodeType="clickEffect">
+                <p:stCondLst>
+                  <p:cond delay="2000"/>
+                </p:stCondLst>
+                <p:childTnLst/>
+              </p:cTn>
+            </p:par>
+            <p:par>
+              <p:cTn id="21" fill="hold" presetID="10" presetClass="entr" presetSubtype="0" dur="600" nodeType="clickEffect">
+                <p:stCondLst>
+                  <p:cond delay="2200"/>
+                </p:stCondLst>
+                <p:childTnLst/>
+              </p:cTn>
+            </p:par>
+            <p:par>
+              <p:cTn id="22" fill="hold" presetID="10" presetClass="entr" presetSubtype="0" dur="600" nodeType="clickEffect">
+                <p:stCondLst>
+                  <p:cond delay="2400"/>
+                </p:stCondLst>
+                <p:childTnLst/>
+              </p:cTn>
+            </p:par>
+            <p:par>
+              <p:cTn id="23" fill="hold" presetID="10" presetClass="entr" presetSubtype="0" dur="600" nodeType="clickEffect">
+                <p:stCondLst>
+                  <p:cond delay="2600"/>
+                </p:stCondLst>
+                <p:childTnLst/>
+              </p:cTn>
+            </p:par>
+            <p:par>
+              <p:cTn id="24" fill="hold" presetID="10" presetClass="entr" presetSubtype="0" dur="600" nodeType="clickEffect">
+                <p:stCondLst>
+                  <p:cond delay="2800"/>
+                </p:stCondLst>
+                <p:childTnLst/>
+              </p:cTn>
+            </p:par>
+            <p:par>
+              <p:cTn id="25" fill="hold" presetID="10" presetClass="entr" presetSubtype="0" dur="600" nodeType="clickEffect">
+                <p:stCondLst>
+                  <p:cond delay="3000"/>
+                </p:stCondLst>
+                <p:childTnLst/>
+              </p:cTn>
+            </p:par>
+            <p:par>
+              <p:cTn id="26" fill="hold" presetID="10" presetClass="entr" presetSubtype="0" dur="600" nodeType="clickEffect">
+                <p:stCondLst>
+                  <p:cond delay="3200"/>
+                </p:stCondLst>
+                <p:childTnLst/>
+              </p:cTn>
+            </p:par>
+            <p:par>
+              <p:cTn id="27" fill="hold" presetID="10" presetClass="entr" presetSubtype="0" dur="600" nodeType="clickEffect">
+                <p:stCondLst>
+                  <p:cond delay="3400"/>
+                </p:stCondLst>
+                <p:childTnLst/>
+              </p:cTn>
+            </p:par>
+            <p:par>
+              <p:cTn id="28" fill="hold" presetID="10" presetClass="entr" presetSubtype="0" dur="600" nodeType="clickEffect">
+                <p:stCondLst>
+                  <p:cond delay="3600"/>
+                </p:stCondLst>
+                <p:childTnLst/>
+              </p:cTn>
+            </p:par>
+            <p:par>
+              <p:cTn id="29" fill="hold" presetID="10" presetClass="entr" presetSubtype="0" dur="700" nodeType="clickEffect">
+                <p:stCondLst>
+                  <p:cond delay="3800"/>
+                </p:stCondLst>
+                <p:childTnLst/>
+              </p:cTn>
+            </p:par>
+            <p:par>
+              <p:cTn id="30" fill="hold" presetID="10" presetClass="entr" presetSubtype="0" dur="600" nodeType="clickEffect">
+                <p:stCondLst>
+                  <p:cond delay="4000"/>
+                </p:stCondLst>
+                <p:childTnLst/>
+              </p:cTn>
+            </p:par>
+            <p:par>
+              <p:cTn id="31" fill="hold" presetID="10" presetClass="entr" presetSubtype="0" dur="600" nodeType="clickEffect">
+                <p:stCondLst>
+                  <p:cond delay="4200"/>
+                </p:stCondLst>
+                <p:childTnLst/>
+              </p:cTn>
+            </p:par>
+          </p:childTnLst>
+        </p:cTn>
+      </p:par>
+    </p:tnLst>
+  </p:timing>
 </p:sld>
 </file>
 
@@ -14809,232 +15123,6 @@
   <p:clrMapOvr>
     <a:masterClrMapping/>
   </p:clrMapOvr>
-  <p:timing>
-    <p:tnLst>
-      <p:par>
-        <p:cTn id="1" dur="indefinite" restart="whenNotActive" nodeType="tmRoot">
-          <p:childTnLst>
-            <p:par>
-              <p:cTn id="10" fill="hold" presetID="10" presetClass="entr" presetSubtype="0" dur="600" nodeType="clickEffect">
-                <p:stCondLst>
-                  <p:cond delay="0" evt="onClick"/>
-                </p:stCondLst>
-                <p:childTnLst/>
-              </p:cTn>
-            </p:par>
-            <p:par>
-              <p:cTn id="11" fill="hold" presetID="10" presetClass="entr" presetSubtype="0" dur="600" nodeType="clickEffect">
-                <p:stCondLst>
-                  <p:cond delay="200"/>
-                </p:stCondLst>
-                <p:childTnLst/>
-              </p:cTn>
-            </p:par>
-            <p:par>
-              <p:cTn id="12" fill="hold" presetID="10" presetClass="entr" presetSubtype="0" dur="600" nodeType="clickEffect">
-                <p:stCondLst>
-                  <p:cond delay="400"/>
-                </p:stCondLst>
-                <p:childTnLst/>
-              </p:cTn>
-            </p:par>
-            <p:par>
-              <p:cTn id="13" fill="hold" presetID="10" presetClass="entr" presetSubtype="0" dur="600" nodeType="clickEffect">
-                <p:stCondLst>
-                  <p:cond delay="600"/>
-                </p:stCondLst>
-                <p:childTnLst/>
-              </p:cTn>
-            </p:par>
-            <p:par>
-              <p:cTn id="14" fill="hold" presetID="10" presetClass="entr" presetSubtype="0" dur="600" nodeType="clickEffect">
-                <p:stCondLst>
-                  <p:cond delay="800"/>
-                </p:stCondLst>
-                <p:childTnLst/>
-              </p:cTn>
-            </p:par>
-            <p:par>
-              <p:cTn id="15" fill="hold" presetID="10" presetClass="entr" presetSubtype="0" dur="600" nodeType="clickEffect">
-                <p:stCondLst>
-                  <p:cond delay="1000"/>
-                </p:stCondLst>
-                <p:childTnLst/>
-              </p:cTn>
-            </p:par>
-            <p:par>
-              <p:cTn id="16" fill="hold" presetID="10" presetClass="entr" presetSubtype="0" dur="500" nodeType="clickEffect">
-                <p:stCondLst>
-                  <p:cond delay="1200"/>
-                </p:stCondLst>
-                <p:childTnLst/>
-              </p:cTn>
-            </p:par>
-            <p:par>
-              <p:cTn id="17" fill="hold" presetID="10" presetClass="entr" presetSubtype="0" dur="700" nodeType="clickEffect">
-                <p:stCondLst>
-                  <p:cond delay="1400"/>
-                </p:stCondLst>
-                <p:childTnLst/>
-              </p:cTn>
-            </p:par>
-            <p:par>
-              <p:cTn id="18" fill="hold" presetID="10" presetClass="entr" presetSubtype="0" dur="600" nodeType="clickEffect">
-                <p:stCondLst>
-                  <p:cond delay="1600"/>
-                </p:stCondLst>
-                <p:childTnLst/>
-              </p:cTn>
-            </p:par>
-            <p:par>
-              <p:cTn id="19" fill="hold" presetID="10" presetClass="entr" presetSubtype="0" dur="600" nodeType="clickEffect">
-                <p:stCondLst>
-                  <p:cond delay="1800"/>
-                </p:stCondLst>
-                <p:childTnLst/>
-              </p:cTn>
-            </p:par>
-            <p:par>
-              <p:cTn id="20" fill="hold" presetID="10" presetClass="entr" presetSubtype="0" dur="500" nodeType="clickEffect">
-                <p:stCondLst>
-                  <p:cond delay="2000"/>
-                </p:stCondLst>
-                <p:childTnLst/>
-              </p:cTn>
-            </p:par>
-            <p:par>
-              <p:cTn id="21" fill="hold" presetID="10" presetClass="entr" presetSubtype="0" dur="600" nodeType="clickEffect">
-                <p:stCondLst>
-                  <p:cond delay="2200"/>
-                </p:stCondLst>
-                <p:childTnLst/>
-              </p:cTn>
-            </p:par>
-            <p:par>
-              <p:cTn id="22" fill="hold" presetID="10" presetClass="entr" presetSubtype="0" dur="600" nodeType="clickEffect">
-                <p:stCondLst>
-                  <p:cond delay="2400"/>
-                </p:stCondLst>
-                <p:childTnLst/>
-              </p:cTn>
-            </p:par>
-            <p:par>
-              <p:cTn id="23" fill="hold" presetID="10" presetClass="entr" presetSubtype="0" dur="600" nodeType="clickEffect">
-                <p:stCondLst>
-                  <p:cond delay="2600"/>
-                </p:stCondLst>
-                <p:childTnLst/>
-              </p:cTn>
-            </p:par>
-            <p:par>
-              <p:cTn id="24" fill="hold" presetID="10" presetClass="entr" presetSubtype="0" dur="600" nodeType="clickEffect">
-                <p:stCondLst>
-                  <p:cond delay="2800"/>
-                </p:stCondLst>
-                <p:childTnLst/>
-              </p:cTn>
-            </p:par>
-            <p:par>
-              <p:cTn id="25" fill="hold" presetID="10" presetClass="entr" presetSubtype="0" dur="500" nodeType="clickEffect">
-                <p:stCondLst>
-                  <p:cond delay="3000"/>
-                </p:stCondLst>
-                <p:childTnLst/>
-              </p:cTn>
-            </p:par>
-            <p:par>
-              <p:cTn id="26" fill="hold" presetID="10" presetClass="entr" presetSubtype="0" dur="600" nodeType="clickEffect">
-                <p:stCondLst>
-                  <p:cond delay="3200"/>
-                </p:stCondLst>
-                <p:childTnLst/>
-              </p:cTn>
-            </p:par>
-            <p:par>
-              <p:cTn id="27" fill="hold" presetID="10" presetClass="entr" presetSubtype="0" dur="600" nodeType="clickEffect">
-                <p:stCondLst>
-                  <p:cond delay="3400"/>
-                </p:stCondLst>
-                <p:childTnLst/>
-              </p:cTn>
-            </p:par>
-            <p:par>
-              <p:cTn id="28" fill="hold" presetID="10" presetClass="entr" presetSubtype="0" dur="600" nodeType="clickEffect">
-                <p:stCondLst>
-                  <p:cond delay="3600"/>
-                </p:stCondLst>
-                <p:childTnLst/>
-              </p:cTn>
-            </p:par>
-            <p:par>
-              <p:cTn id="29" fill="hold" presetID="10" presetClass="entr" presetSubtype="0" dur="600" nodeType="clickEffect">
-                <p:stCondLst>
-                  <p:cond delay="3800"/>
-                </p:stCondLst>
-                <p:childTnLst/>
-              </p:cTn>
-            </p:par>
-            <p:par>
-              <p:cTn id="30" fill="hold" presetID="10" presetClass="entr" presetSubtype="0" dur="600" nodeType="clickEffect">
-                <p:stCondLst>
-                  <p:cond delay="4000"/>
-                </p:stCondLst>
-                <p:childTnLst/>
-              </p:cTn>
-            </p:par>
-            <p:par>
-              <p:cTn id="31" fill="hold" presetID="10" presetClass="entr" presetSubtype="0" dur="600" nodeType="clickEffect">
-                <p:stCondLst>
-                  <p:cond delay="4200"/>
-                </p:stCondLst>
-                <p:childTnLst/>
-              </p:cTn>
-            </p:par>
-            <p:par>
-              <p:cTn id="32" fill="hold" presetID="10" presetClass="entr" presetSubtype="0" dur="700" nodeType="clickEffect">
-                <p:stCondLst>
-                  <p:cond delay="4400"/>
-                </p:stCondLst>
-                <p:childTnLst/>
-              </p:cTn>
-            </p:par>
-            <p:par>
-              <p:cTn id="33" fill="hold" presetID="10" presetClass="entr" presetSubtype="0" dur="600" nodeType="clickEffect">
-                <p:stCondLst>
-                  <p:cond delay="4600"/>
-                </p:stCondLst>
-                <p:childTnLst/>
-              </p:cTn>
-            </p:par>
-            <p:par>
-              <p:cTn id="34" fill="hold" presetID="10" presetClass="entr" presetSubtype="0" dur="600" nodeType="clickEffect">
-                <p:stCondLst>
-                  <p:cond delay="4800"/>
-                </p:stCondLst>
-                <p:childTnLst/>
-              </p:cTn>
-            </p:par>
-            <p:par>
-              <p:cTn id="35" fill="hold" presetID="10" presetClass="entr" presetSubtype="0" dur="600" nodeType="clickEffect">
-                <p:stCondLst>
-                  <p:cond delay="5000"/>
-                </p:stCondLst>
-                <p:childTnLst/>
-              </p:cTn>
-            </p:par>
-            <p:par>
-              <p:cTn id="36" fill="hold" presetID="10" presetClass="entr" presetSubtype="0" dur="600" nodeType="clickEffect">
-                <p:stCondLst>
-                  <p:cond delay="5200"/>
-                </p:stCondLst>
-                <p:childTnLst/>
-              </p:cTn>
-            </p:par>
-          </p:childTnLst>
-        </p:cTn>
-      </p:par>
-    </p:tnLst>
-  </p:timing>
 </p:sld>
 </file>
 
@@ -15884,8 +15972,8 @@
         </p:nvSpPr>
         <p:spPr>
           <a:xfrm>
-            <a:off x="770633" y="88473"/>
-            <a:ext cx="3114261" cy="36576"/>
+            <a:off x="482972" y="131602"/>
+            <a:ext cx="2388952" cy="36576"/>
           </a:xfrm>
           <a:prstGeom prst="rect">
             <a:avLst/>
@@ -15932,7 +16020,7 @@
             <p:par>
               <p:cTn id="10" fill="hold" presetID="10" presetClass="entr" presetSubtype="0" dur="600" nodeType="clickEffect">
                 <p:stCondLst>
-                  <p:cond delay="0" evt="onClick"/>
+                  <p:cond evt="onClick" delay="0"/>
                 </p:stCondLst>
                 <p:childTnLst/>
               </p:cTn>
@@ -17347,8 +17435,8 @@
         </p:nvSpPr>
         <p:spPr>
           <a:xfrm>
-            <a:off x="470082" y="82657"/>
-            <a:ext cx="1858696" cy="36576"/>
+            <a:off x="783792" y="84982"/>
+            <a:ext cx="1821004" cy="36576"/>
           </a:xfrm>
           <a:prstGeom prst="rect">
             <a:avLst/>
@@ -17395,7 +17483,7 @@
             <p:par>
               <p:cTn id="10" fill="hold" presetID="10" presetClass="entr" presetSubtype="0" dur="600" nodeType="clickEffect">
                 <p:stCondLst>
-                  <p:cond delay="0" evt="onClick"/>
+                  <p:cond evt="onClick" delay="0"/>
                 </p:stCondLst>
                 <p:childTnLst/>
               </p:cTn>
@@ -17441,7 +17529,7 @@
               </p:cTn>
             </p:par>
             <p:par>
-              <p:cTn id="16" fill="hold" presetID="10" presetClass="entr" presetSubtype="0" dur="600" nodeType="clickEffect">
+              <p:cTn id="16" fill="hold" presetID="10" presetClass="entr" presetSubtype="0" dur="700" nodeType="clickEffect">
                 <p:stCondLst>
                   <p:cond delay="1200"/>
                 </p:stCondLst>
@@ -17718,8 +17806,8 @@
         </p:nvSpPr>
         <p:spPr>
           <a:xfrm>
-            <a:off x="751810" y="132989"/>
-            <a:ext cx="2541463" cy="36576"/>
+            <a:off x="776836" y="130472"/>
+            <a:ext cx="1605314" cy="36576"/>
           </a:xfrm>
           <a:prstGeom prst="rect">
             <a:avLst/>
@@ -17766,13 +17854,13 @@
             <p:par>
               <p:cTn id="10" fill="hold" presetID="10" presetClass="entr" presetSubtype="0" dur="600" nodeType="clickEffect">
                 <p:stCondLst>
-                  <p:cond delay="0" evt="onClick"/>
-                </p:stCondLst>
-                <p:childTnLst/>
-              </p:cTn>
-            </p:par>
-            <p:par>
-              <p:cTn id="11" fill="hold" presetID="10" presetClass="entr" presetSubtype="0" dur="500" nodeType="clickEffect">
+                  <p:cond evt="onClick" delay="0"/>
+                </p:stCondLst>
+                <p:childTnLst/>
+              </p:cTn>
+            </p:par>
+            <p:par>
+              <p:cTn id="11" fill="hold" presetID="10" presetClass="entr" presetSubtype="0" dur="600" nodeType="clickEffect">
                 <p:stCondLst>
                   <p:cond delay="200"/>
                 </p:stCondLst>
@@ -17788,7 +17876,7 @@
               </p:cTn>
             </p:par>
             <p:par>
-              <p:cTn id="13" fill="hold" presetID="10" presetClass="entr" presetSubtype="0" dur="600" nodeType="clickEffect">
+              <p:cTn id="13" fill="hold" presetID="10" presetClass="entr" presetSubtype="0" dur="500" nodeType="clickEffect">
                 <p:stCondLst>
                   <p:cond delay="600"/>
                 </p:stCondLst>

</xml_diff>